<commit_message>
fix: enforce SVG compliance in examples and correct id attribute false positive
- Fix non-compliant SVG features in examples/*/svg_output/: remove clipPath,
  marker/marker-end, rgba(), <g opacity>, <image opacity>; add <polygon> arrows
- Regenerate svg_final and PPTX for all 12 affected example projects
- Fix svg_quality_checker.py false positive: id in <defs> (linearGradient/filter)
  is required by SVG spec, only flag id when used with <style>
- Update id attribute policy across docs and templates (10 files)
</commit_message>
<xml_diff>
--- a/examples/demo_project_intro_ppt169_20251211/demo_project_intro.pptx
+++ b/examples/demo_project_intro_ppt169_20251211/demo_project_intro.pptx
@@ -114,6 +114,566 @@
     </a:lvl9pPr>
   </p:defaultTextStyle>
 </p:presentation>
+</file>
+
+<file path=ppt/notesSlides/notesSlide1.xml><?xml version="1.0" encoding="utf-8"?>
+<p:notes xmlns:a="http://schemas.openxmlformats.org/drawingml/2006/main" xmlns:r="http://schemas.openxmlformats.org/officeDocument/2006/relationships" xmlns:p="http://schemas.openxmlformats.org/presentationml/2006/main">
+  <p:cSld>
+    <p:spTree>
+      <p:nvGrpSpPr>
+        <p:cNvPr id="1" name=""/>
+        <p:cNvGrpSpPr/>
+        <p:nvPr/>
+      </p:nvGrpSpPr>
+      <p:grpSpPr>
+        <a:xfrm>
+          <a:off x="0" y="0"/>
+          <a:ext cx="0" cy="0"/>
+          <a:chOff x="0" y="0"/>
+          <a:chExt cx="0" cy="0"/>
+        </a:xfrm>
+      </p:grpSpPr>
+      <p:sp>
+        <p:nvSpPr>
+          <p:cNvPr id="2" name="Slide Image Placeholder 1"/>
+          <p:cNvSpPr>
+            <a:spLocks noGrp="1" noRot="1" noChangeAspect="1"/>
+          </p:cNvSpPr>
+          <p:nvPr>
+            <p:ph type="sldImg"/>
+          </p:nvPr>
+        </p:nvSpPr>
+        <p:spPr/>
+      </p:sp>
+      <p:sp>
+        <p:nvSpPr>
+          <p:cNvPr id="3" name="Notes Placeholder 2"/>
+          <p:cNvSpPr>
+            <a:spLocks noGrp="1"/>
+          </p:cNvSpPr>
+          <p:nvPr>
+            <p:ph type="body" idx="1"/>
+          </p:nvPr>
+        </p:nvSpPr>
+        <p:spPr/>
+        <p:txBody>
+          <a:bodyPr/>
+          <a:lstStyle/>
+          <a:p>
+            <a:endParaRPr lang="zh-CN" dirty="0"/>
+          </a:p>
+        </p:txBody>
+      </p:sp>
+    </p:spTree>
+  </p:cSld>
+  <p:clrMapOvr>
+    <a:masterClrMapping/>
+  </p:clrMapOvr>
+</p:notes>
+</file>
+
+<file path=ppt/notesSlides/notesSlide10.xml><?xml version="1.0" encoding="utf-8"?>
+<p:notes xmlns:a="http://schemas.openxmlformats.org/drawingml/2006/main" xmlns:r="http://schemas.openxmlformats.org/officeDocument/2006/relationships" xmlns:p="http://schemas.openxmlformats.org/presentationml/2006/main">
+  <p:cSld>
+    <p:spTree>
+      <p:nvGrpSpPr>
+        <p:cNvPr id="1" name=""/>
+        <p:cNvGrpSpPr/>
+        <p:nvPr/>
+      </p:nvGrpSpPr>
+      <p:grpSpPr>
+        <a:xfrm>
+          <a:off x="0" y="0"/>
+          <a:ext cx="0" cy="0"/>
+          <a:chOff x="0" y="0"/>
+          <a:chExt cx="0" cy="0"/>
+        </a:xfrm>
+      </p:grpSpPr>
+      <p:sp>
+        <p:nvSpPr>
+          <p:cNvPr id="2" name="Slide Image Placeholder 1"/>
+          <p:cNvSpPr>
+            <a:spLocks noGrp="1" noRot="1" noChangeAspect="1"/>
+          </p:cNvSpPr>
+          <p:nvPr>
+            <p:ph type="sldImg"/>
+          </p:nvPr>
+        </p:nvSpPr>
+        <p:spPr/>
+      </p:sp>
+      <p:sp>
+        <p:nvSpPr>
+          <p:cNvPr id="3" name="Notes Placeholder 2"/>
+          <p:cNvSpPr>
+            <a:spLocks noGrp="1"/>
+          </p:cNvSpPr>
+          <p:nvPr>
+            <p:ph type="body" idx="1"/>
+          </p:nvPr>
+        </p:nvSpPr>
+        <p:spPr/>
+        <p:txBody>
+          <a:bodyPr/>
+          <a:lstStyle/>
+          <a:p>
+            <a:endParaRPr lang="zh-CN" dirty="0"/>
+          </a:p>
+        </p:txBody>
+      </p:sp>
+    </p:spTree>
+  </p:cSld>
+  <p:clrMapOvr>
+    <a:masterClrMapping/>
+  </p:clrMapOvr>
+</p:notes>
+</file>
+
+<file path=ppt/notesSlides/notesSlide2.xml><?xml version="1.0" encoding="utf-8"?>
+<p:notes xmlns:a="http://schemas.openxmlformats.org/drawingml/2006/main" xmlns:r="http://schemas.openxmlformats.org/officeDocument/2006/relationships" xmlns:p="http://schemas.openxmlformats.org/presentationml/2006/main">
+  <p:cSld>
+    <p:spTree>
+      <p:nvGrpSpPr>
+        <p:cNvPr id="1" name=""/>
+        <p:cNvGrpSpPr/>
+        <p:nvPr/>
+      </p:nvGrpSpPr>
+      <p:grpSpPr>
+        <a:xfrm>
+          <a:off x="0" y="0"/>
+          <a:ext cx="0" cy="0"/>
+          <a:chOff x="0" y="0"/>
+          <a:chExt cx="0" cy="0"/>
+        </a:xfrm>
+      </p:grpSpPr>
+      <p:sp>
+        <p:nvSpPr>
+          <p:cNvPr id="2" name="Slide Image Placeholder 1"/>
+          <p:cNvSpPr>
+            <a:spLocks noGrp="1" noRot="1" noChangeAspect="1"/>
+          </p:cNvSpPr>
+          <p:nvPr>
+            <p:ph type="sldImg"/>
+          </p:nvPr>
+        </p:nvSpPr>
+        <p:spPr/>
+      </p:sp>
+      <p:sp>
+        <p:nvSpPr>
+          <p:cNvPr id="3" name="Notes Placeholder 2"/>
+          <p:cNvSpPr>
+            <a:spLocks noGrp="1"/>
+          </p:cNvSpPr>
+          <p:nvPr>
+            <p:ph type="body" idx="1"/>
+          </p:nvPr>
+        </p:nvSpPr>
+        <p:spPr/>
+        <p:txBody>
+          <a:bodyPr/>
+          <a:lstStyle/>
+          <a:p>
+            <a:endParaRPr lang="zh-CN" dirty="0"/>
+          </a:p>
+        </p:txBody>
+      </p:sp>
+    </p:spTree>
+  </p:cSld>
+  <p:clrMapOvr>
+    <a:masterClrMapping/>
+  </p:clrMapOvr>
+</p:notes>
+</file>
+
+<file path=ppt/notesSlides/notesSlide3.xml><?xml version="1.0" encoding="utf-8"?>
+<p:notes xmlns:a="http://schemas.openxmlformats.org/drawingml/2006/main" xmlns:r="http://schemas.openxmlformats.org/officeDocument/2006/relationships" xmlns:p="http://schemas.openxmlformats.org/presentationml/2006/main">
+  <p:cSld>
+    <p:spTree>
+      <p:nvGrpSpPr>
+        <p:cNvPr id="1" name=""/>
+        <p:cNvGrpSpPr/>
+        <p:nvPr/>
+      </p:nvGrpSpPr>
+      <p:grpSpPr>
+        <a:xfrm>
+          <a:off x="0" y="0"/>
+          <a:ext cx="0" cy="0"/>
+          <a:chOff x="0" y="0"/>
+          <a:chExt cx="0" cy="0"/>
+        </a:xfrm>
+      </p:grpSpPr>
+      <p:sp>
+        <p:nvSpPr>
+          <p:cNvPr id="2" name="Slide Image Placeholder 1"/>
+          <p:cNvSpPr>
+            <a:spLocks noGrp="1" noRot="1" noChangeAspect="1"/>
+          </p:cNvSpPr>
+          <p:nvPr>
+            <p:ph type="sldImg"/>
+          </p:nvPr>
+        </p:nvSpPr>
+        <p:spPr/>
+      </p:sp>
+      <p:sp>
+        <p:nvSpPr>
+          <p:cNvPr id="3" name="Notes Placeholder 2"/>
+          <p:cNvSpPr>
+            <a:spLocks noGrp="1"/>
+          </p:cNvSpPr>
+          <p:nvPr>
+            <p:ph type="body" idx="1"/>
+          </p:nvPr>
+        </p:nvSpPr>
+        <p:spPr/>
+        <p:txBody>
+          <a:bodyPr/>
+          <a:lstStyle/>
+          <a:p>
+            <a:endParaRPr lang="zh-CN" dirty="0"/>
+          </a:p>
+        </p:txBody>
+      </p:sp>
+    </p:spTree>
+  </p:cSld>
+  <p:clrMapOvr>
+    <a:masterClrMapping/>
+  </p:clrMapOvr>
+</p:notes>
+</file>
+
+<file path=ppt/notesSlides/notesSlide4.xml><?xml version="1.0" encoding="utf-8"?>
+<p:notes xmlns:a="http://schemas.openxmlformats.org/drawingml/2006/main" xmlns:r="http://schemas.openxmlformats.org/officeDocument/2006/relationships" xmlns:p="http://schemas.openxmlformats.org/presentationml/2006/main">
+  <p:cSld>
+    <p:spTree>
+      <p:nvGrpSpPr>
+        <p:cNvPr id="1" name=""/>
+        <p:cNvGrpSpPr/>
+        <p:nvPr/>
+      </p:nvGrpSpPr>
+      <p:grpSpPr>
+        <a:xfrm>
+          <a:off x="0" y="0"/>
+          <a:ext cx="0" cy="0"/>
+          <a:chOff x="0" y="0"/>
+          <a:chExt cx="0" cy="0"/>
+        </a:xfrm>
+      </p:grpSpPr>
+      <p:sp>
+        <p:nvSpPr>
+          <p:cNvPr id="2" name="Slide Image Placeholder 1"/>
+          <p:cNvSpPr>
+            <a:spLocks noGrp="1" noRot="1" noChangeAspect="1"/>
+          </p:cNvSpPr>
+          <p:nvPr>
+            <p:ph type="sldImg"/>
+          </p:nvPr>
+        </p:nvSpPr>
+        <p:spPr/>
+      </p:sp>
+      <p:sp>
+        <p:nvSpPr>
+          <p:cNvPr id="3" name="Notes Placeholder 2"/>
+          <p:cNvSpPr>
+            <a:spLocks noGrp="1"/>
+          </p:cNvSpPr>
+          <p:nvPr>
+            <p:ph type="body" idx="1"/>
+          </p:nvPr>
+        </p:nvSpPr>
+        <p:spPr/>
+        <p:txBody>
+          <a:bodyPr/>
+          <a:lstStyle/>
+          <a:p>
+            <a:endParaRPr lang="zh-CN" dirty="0"/>
+          </a:p>
+        </p:txBody>
+      </p:sp>
+    </p:spTree>
+  </p:cSld>
+  <p:clrMapOvr>
+    <a:masterClrMapping/>
+  </p:clrMapOvr>
+</p:notes>
+</file>
+
+<file path=ppt/notesSlides/notesSlide5.xml><?xml version="1.0" encoding="utf-8"?>
+<p:notes xmlns:a="http://schemas.openxmlformats.org/drawingml/2006/main" xmlns:r="http://schemas.openxmlformats.org/officeDocument/2006/relationships" xmlns:p="http://schemas.openxmlformats.org/presentationml/2006/main">
+  <p:cSld>
+    <p:spTree>
+      <p:nvGrpSpPr>
+        <p:cNvPr id="1" name=""/>
+        <p:cNvGrpSpPr/>
+        <p:nvPr/>
+      </p:nvGrpSpPr>
+      <p:grpSpPr>
+        <a:xfrm>
+          <a:off x="0" y="0"/>
+          <a:ext cx="0" cy="0"/>
+          <a:chOff x="0" y="0"/>
+          <a:chExt cx="0" cy="0"/>
+        </a:xfrm>
+      </p:grpSpPr>
+      <p:sp>
+        <p:nvSpPr>
+          <p:cNvPr id="2" name="Slide Image Placeholder 1"/>
+          <p:cNvSpPr>
+            <a:spLocks noGrp="1" noRot="1" noChangeAspect="1"/>
+          </p:cNvSpPr>
+          <p:nvPr>
+            <p:ph type="sldImg"/>
+          </p:nvPr>
+        </p:nvSpPr>
+        <p:spPr/>
+      </p:sp>
+      <p:sp>
+        <p:nvSpPr>
+          <p:cNvPr id="3" name="Notes Placeholder 2"/>
+          <p:cNvSpPr>
+            <a:spLocks noGrp="1"/>
+          </p:cNvSpPr>
+          <p:nvPr>
+            <p:ph type="body" idx="1"/>
+          </p:nvPr>
+        </p:nvSpPr>
+        <p:spPr/>
+        <p:txBody>
+          <a:bodyPr/>
+          <a:lstStyle/>
+          <a:p>
+            <a:endParaRPr lang="zh-CN" dirty="0"/>
+          </a:p>
+        </p:txBody>
+      </p:sp>
+    </p:spTree>
+  </p:cSld>
+  <p:clrMapOvr>
+    <a:masterClrMapping/>
+  </p:clrMapOvr>
+</p:notes>
+</file>
+
+<file path=ppt/notesSlides/notesSlide6.xml><?xml version="1.0" encoding="utf-8"?>
+<p:notes xmlns:a="http://schemas.openxmlformats.org/drawingml/2006/main" xmlns:r="http://schemas.openxmlformats.org/officeDocument/2006/relationships" xmlns:p="http://schemas.openxmlformats.org/presentationml/2006/main">
+  <p:cSld>
+    <p:spTree>
+      <p:nvGrpSpPr>
+        <p:cNvPr id="1" name=""/>
+        <p:cNvGrpSpPr/>
+        <p:nvPr/>
+      </p:nvGrpSpPr>
+      <p:grpSpPr>
+        <a:xfrm>
+          <a:off x="0" y="0"/>
+          <a:ext cx="0" cy="0"/>
+          <a:chOff x="0" y="0"/>
+          <a:chExt cx="0" cy="0"/>
+        </a:xfrm>
+      </p:grpSpPr>
+      <p:sp>
+        <p:nvSpPr>
+          <p:cNvPr id="2" name="Slide Image Placeholder 1"/>
+          <p:cNvSpPr>
+            <a:spLocks noGrp="1" noRot="1" noChangeAspect="1"/>
+          </p:cNvSpPr>
+          <p:nvPr>
+            <p:ph type="sldImg"/>
+          </p:nvPr>
+        </p:nvSpPr>
+        <p:spPr/>
+      </p:sp>
+      <p:sp>
+        <p:nvSpPr>
+          <p:cNvPr id="3" name="Notes Placeholder 2"/>
+          <p:cNvSpPr>
+            <a:spLocks noGrp="1"/>
+          </p:cNvSpPr>
+          <p:nvPr>
+            <p:ph type="body" idx="1"/>
+          </p:nvPr>
+        </p:nvSpPr>
+        <p:spPr/>
+        <p:txBody>
+          <a:bodyPr/>
+          <a:lstStyle/>
+          <a:p>
+            <a:endParaRPr lang="zh-CN" dirty="0"/>
+          </a:p>
+        </p:txBody>
+      </p:sp>
+    </p:spTree>
+  </p:cSld>
+  <p:clrMapOvr>
+    <a:masterClrMapping/>
+  </p:clrMapOvr>
+</p:notes>
+</file>
+
+<file path=ppt/notesSlides/notesSlide7.xml><?xml version="1.0" encoding="utf-8"?>
+<p:notes xmlns:a="http://schemas.openxmlformats.org/drawingml/2006/main" xmlns:r="http://schemas.openxmlformats.org/officeDocument/2006/relationships" xmlns:p="http://schemas.openxmlformats.org/presentationml/2006/main">
+  <p:cSld>
+    <p:spTree>
+      <p:nvGrpSpPr>
+        <p:cNvPr id="1" name=""/>
+        <p:cNvGrpSpPr/>
+        <p:nvPr/>
+      </p:nvGrpSpPr>
+      <p:grpSpPr>
+        <a:xfrm>
+          <a:off x="0" y="0"/>
+          <a:ext cx="0" cy="0"/>
+          <a:chOff x="0" y="0"/>
+          <a:chExt cx="0" cy="0"/>
+        </a:xfrm>
+      </p:grpSpPr>
+      <p:sp>
+        <p:nvSpPr>
+          <p:cNvPr id="2" name="Slide Image Placeholder 1"/>
+          <p:cNvSpPr>
+            <a:spLocks noGrp="1" noRot="1" noChangeAspect="1"/>
+          </p:cNvSpPr>
+          <p:nvPr>
+            <p:ph type="sldImg"/>
+          </p:nvPr>
+        </p:nvSpPr>
+        <p:spPr/>
+      </p:sp>
+      <p:sp>
+        <p:nvSpPr>
+          <p:cNvPr id="3" name="Notes Placeholder 2"/>
+          <p:cNvSpPr>
+            <a:spLocks noGrp="1"/>
+          </p:cNvSpPr>
+          <p:nvPr>
+            <p:ph type="body" idx="1"/>
+          </p:nvPr>
+        </p:nvSpPr>
+        <p:spPr/>
+        <p:txBody>
+          <a:bodyPr/>
+          <a:lstStyle/>
+          <a:p>
+            <a:endParaRPr lang="zh-CN" dirty="0"/>
+          </a:p>
+        </p:txBody>
+      </p:sp>
+    </p:spTree>
+  </p:cSld>
+  <p:clrMapOvr>
+    <a:masterClrMapping/>
+  </p:clrMapOvr>
+</p:notes>
+</file>
+
+<file path=ppt/notesSlides/notesSlide8.xml><?xml version="1.0" encoding="utf-8"?>
+<p:notes xmlns:a="http://schemas.openxmlformats.org/drawingml/2006/main" xmlns:r="http://schemas.openxmlformats.org/officeDocument/2006/relationships" xmlns:p="http://schemas.openxmlformats.org/presentationml/2006/main">
+  <p:cSld>
+    <p:spTree>
+      <p:nvGrpSpPr>
+        <p:cNvPr id="1" name=""/>
+        <p:cNvGrpSpPr/>
+        <p:nvPr/>
+      </p:nvGrpSpPr>
+      <p:grpSpPr>
+        <a:xfrm>
+          <a:off x="0" y="0"/>
+          <a:ext cx="0" cy="0"/>
+          <a:chOff x="0" y="0"/>
+          <a:chExt cx="0" cy="0"/>
+        </a:xfrm>
+      </p:grpSpPr>
+      <p:sp>
+        <p:nvSpPr>
+          <p:cNvPr id="2" name="Slide Image Placeholder 1"/>
+          <p:cNvSpPr>
+            <a:spLocks noGrp="1" noRot="1" noChangeAspect="1"/>
+          </p:cNvSpPr>
+          <p:nvPr>
+            <p:ph type="sldImg"/>
+          </p:nvPr>
+        </p:nvSpPr>
+        <p:spPr/>
+      </p:sp>
+      <p:sp>
+        <p:nvSpPr>
+          <p:cNvPr id="3" name="Notes Placeholder 2"/>
+          <p:cNvSpPr>
+            <a:spLocks noGrp="1"/>
+          </p:cNvSpPr>
+          <p:nvPr>
+            <p:ph type="body" idx="1"/>
+          </p:nvPr>
+        </p:nvSpPr>
+        <p:spPr/>
+        <p:txBody>
+          <a:bodyPr/>
+          <a:lstStyle/>
+          <a:p>
+            <a:endParaRPr lang="zh-CN" dirty="0"/>
+          </a:p>
+        </p:txBody>
+      </p:sp>
+    </p:spTree>
+  </p:cSld>
+  <p:clrMapOvr>
+    <a:masterClrMapping/>
+  </p:clrMapOvr>
+</p:notes>
+</file>
+
+<file path=ppt/notesSlides/notesSlide9.xml><?xml version="1.0" encoding="utf-8"?>
+<p:notes xmlns:a="http://schemas.openxmlformats.org/drawingml/2006/main" xmlns:r="http://schemas.openxmlformats.org/officeDocument/2006/relationships" xmlns:p="http://schemas.openxmlformats.org/presentationml/2006/main">
+  <p:cSld>
+    <p:spTree>
+      <p:nvGrpSpPr>
+        <p:cNvPr id="1" name=""/>
+        <p:cNvGrpSpPr/>
+        <p:nvPr/>
+      </p:nvGrpSpPr>
+      <p:grpSpPr>
+        <a:xfrm>
+          <a:off x="0" y="0"/>
+          <a:ext cx="0" cy="0"/>
+          <a:chOff x="0" y="0"/>
+          <a:chExt cx="0" cy="0"/>
+        </a:xfrm>
+      </p:grpSpPr>
+      <p:sp>
+        <p:nvSpPr>
+          <p:cNvPr id="2" name="Slide Image Placeholder 1"/>
+          <p:cNvSpPr>
+            <a:spLocks noGrp="1" noRot="1" noChangeAspect="1"/>
+          </p:cNvSpPr>
+          <p:nvPr>
+            <p:ph type="sldImg"/>
+          </p:nvPr>
+        </p:nvSpPr>
+        <p:spPr/>
+      </p:sp>
+      <p:sp>
+        <p:nvSpPr>
+          <p:cNvPr id="3" name="Notes Placeholder 2"/>
+          <p:cNvSpPr>
+            <a:spLocks noGrp="1"/>
+          </p:cNvSpPr>
+          <p:nvPr>
+            <p:ph type="body" idx="1"/>
+          </p:nvPr>
+        </p:nvSpPr>
+        <p:spPr/>
+        <p:txBody>
+          <a:bodyPr/>
+          <a:lstStyle/>
+          <a:p>
+            <a:endParaRPr lang="zh-CN" dirty="0"/>
+          </a:p>
+        </p:txBody>
+      </p:sp>
+    </p:spTree>
+  </p:cSld>
+  <p:clrMapOvr>
+    <a:masterClrMapping/>
+  </p:clrMapOvr>
+</p:notes>
 </file>
 
 <file path=ppt/slideLayouts/slideLayout1.xml><?xml version="1.0" encoding="utf-8"?>

</xml_diff>